<commit_message>
Update trusted AI agents presentation
</commit_message>
<xml_diff>
--- a/presentations/Beyond_the_Demo_Trusted_AI_Agents_MCP_AI_Expo_2026.pptx
+++ b/presentations/Beyond_the_Demo_Trusted_AI_Agents_MCP_AI_Expo_2026.pptx
@@ -2498,7 +2498,7 @@
         </p:blipFill>
         <p:spPr>
           <a:xfrm>
-            <a:off x="0" y="0"/>
+            <a:off x="12032" y="0"/>
             <a:ext cx="12191695" cy="6858000"/>
           </a:xfrm>
           <a:prstGeom prst="rect">
@@ -3401,7 +3401,7 @@
               <a:buNone/>
             </a:pPr>
             <a:r>
-              <a:rPr sz="1700" b="1">
+              <a:rPr lang="en-GB" sz="1700" b="1" dirty="0">
                 <a:solidFill>
                   <a:srgbClr val="F7FAFF"/>
                 </a:solidFill>
@@ -3409,9 +3409,64 @@
                 <a:ea typeface="Inter"/>
                 <a:cs typeface="Inter"/>
               </a:rPr>
-              <a:t>Konstantin Grigorov</a:t>
-            </a:r>
-            <a:endParaRPr sz="1700"/>
+              <a:t>C</a:t>
+            </a:r>
+            <a:r>
+              <a:rPr sz="1700" b="1" dirty="0" err="1">
+                <a:solidFill>
+                  <a:srgbClr val="F7FAFF"/>
+                </a:solidFill>
+                <a:latin typeface="Inter"/>
+                <a:ea typeface="Inter"/>
+                <a:cs typeface="Inter"/>
+              </a:rPr>
+              <a:t>onstantin</a:t>
+            </a:r>
+            <a:r>
+              <a:rPr lang="en-GB" sz="1700" b="1" dirty="0">
+                <a:solidFill>
+                  <a:srgbClr val="F7FAFF"/>
+                </a:solidFill>
+                <a:latin typeface="Inter"/>
+                <a:ea typeface="Inter"/>
+                <a:cs typeface="Inter"/>
+              </a:rPr>
+              <a:t>e</a:t>
+            </a:r>
+            <a:r>
+              <a:rPr sz="1700" b="1" dirty="0">
+                <a:solidFill>
+                  <a:srgbClr val="F7FAFF"/>
+                </a:solidFill>
+                <a:latin typeface="Inter"/>
+                <a:ea typeface="Inter"/>
+                <a:cs typeface="Inter"/>
+              </a:rPr>
+              <a:t> </a:t>
+            </a:r>
+            <a:r>
+              <a:rPr sz="1700" b="1" dirty="0" err="1">
+                <a:solidFill>
+                  <a:srgbClr val="F7FAFF"/>
+                </a:solidFill>
+                <a:latin typeface="Inter"/>
+                <a:ea typeface="Inter"/>
+                <a:cs typeface="Inter"/>
+              </a:rPr>
+              <a:t>Grigoro</a:t>
+            </a:r>
+            <a:r>
+              <a:rPr lang="en-GB" sz="1700" b="1" dirty="0">
+                <a:solidFill>
+                  <a:srgbClr val="F7FAFF"/>
+                </a:solidFill>
+                <a:latin typeface="Inter"/>
+                <a:ea typeface="Inter"/>
+                <a:cs typeface="Inter"/>
+              </a:rPr>
+              <a:t>ff</a:t>
+            </a:r>
+            <a:endParaRPr sz="1700" dirty="0"/>
           </a:p>
         </p:txBody>
       </p:sp>

</xml_diff>